<commit_message>
Last Minute Corrections to links in the provider folder
</commit_message>
<xml_diff>
--- a/dsonjteetersprototype.pptx
+++ b/dsonjteetersprototype.pptx
@@ -5,16 +5,17 @@
     <p:sldMasterId id="2147483661" r:id="rId4"/>
   </p:sldMasterIdLst>
   <p:notesMasterIdLst>
-    <p:notesMasterId r:id="rId9"/>
+    <p:notesMasterId r:id="rId10"/>
   </p:notesMasterIdLst>
   <p:handoutMasterIdLst>
-    <p:handoutMasterId r:id="rId10"/>
+    <p:handoutMasterId r:id="rId11"/>
   </p:handoutMasterIdLst>
   <p:sldIdLst>
     <p:sldId id="390" r:id="rId5"/>
     <p:sldId id="451" r:id="rId6"/>
     <p:sldId id="461" r:id="rId7"/>
-    <p:sldId id="383" r:id="rId8"/>
+    <p:sldId id="462" r:id="rId8"/>
+    <p:sldId id="383" r:id="rId9"/>
   </p:sldIdLst>
   <p:sldSz cx="12192000" cy="6858000"/>
   <p:notesSz cx="6858000" cy="9144000"/>
@@ -130,6 +131,171 @@
     <p1510:client id="{6298690D-E1B3-9E04-9C42-9F2E65F5804E}" v="618" dt="2026-09-24T12:49:01.869"/>
   </p1510:revLst>
 </p1510:revInfo>
+</file>
+
+<file path=ppt/changesInfos/changesInfo1.xml><?xml version="1.0" encoding="utf-8"?>
+<pc:chgInfo xmlns:a="http://schemas.openxmlformats.org/drawingml/2006/main" xmlns:r="http://schemas.openxmlformats.org/officeDocument/2006/relationships" xmlns:ac="http://schemas.microsoft.com/office/drawing/2013/main/command" xmlns:pc="http://schemas.microsoft.com/office/powerpoint/2013/main/command">
+  <pc:docChgLst>
+    <pc:chgData name="Jameson Teeters" userId="277cb491e97d6756" providerId="LiveId" clId="{01F63935-08AB-49D1-B378-3708E68EC584}"/>
+    <pc:docChg chg="custSel addSld modSld">
+      <pc:chgData name="Jameson Teeters" userId="277cb491e97d6756" providerId="LiveId" clId="{01F63935-08AB-49D1-B378-3708E68EC584}" dt="2026-09-24T14:39:31.814" v="1012" actId="1076"/>
+      <pc:docMkLst>
+        <pc:docMk/>
+      </pc:docMkLst>
+      <pc:sldChg chg="addSp delSp modSp new mod">
+        <pc:chgData name="Jameson Teeters" userId="277cb491e97d6756" providerId="LiveId" clId="{01F63935-08AB-49D1-B378-3708E68EC584}" dt="2026-09-24T14:39:31.814" v="1012" actId="1076"/>
+        <pc:sldMkLst>
+          <pc:docMk/>
+          <pc:sldMk cId="1669914685" sldId="462"/>
+        </pc:sldMkLst>
+        <pc:spChg chg="mod">
+          <ac:chgData name="Jameson Teeters" userId="277cb491e97d6756" providerId="LiveId" clId="{01F63935-08AB-49D1-B378-3708E68EC584}" dt="2026-09-24T14:32:00.545" v="19" actId="1076"/>
+          <ac:spMkLst>
+            <pc:docMk/>
+            <pc:sldMk cId="1669914685" sldId="462"/>
+            <ac:spMk id="2" creationId="{F45669BB-F1E9-25E6-255D-9DA1386B8F21}"/>
+          </ac:spMkLst>
+        </pc:spChg>
+        <pc:spChg chg="del">
+          <ac:chgData name="Jameson Teeters" userId="277cb491e97d6756" providerId="LiveId" clId="{01F63935-08AB-49D1-B378-3708E68EC584}" dt="2026-09-24T14:31:55.888" v="18" actId="478"/>
+          <ac:spMkLst>
+            <pc:docMk/>
+            <pc:sldMk cId="1669914685" sldId="462"/>
+            <ac:spMk id="3" creationId="{5F8957D8-4DA8-A6D3-1CDB-BCDA266427CE}"/>
+          </ac:spMkLst>
+        </pc:spChg>
+        <pc:spChg chg="del">
+          <ac:chgData name="Jameson Teeters" userId="277cb491e97d6756" providerId="LiveId" clId="{01F63935-08AB-49D1-B378-3708E68EC584}" dt="2026-09-24T14:31:31.515" v="1" actId="931"/>
+          <ac:spMkLst>
+            <pc:docMk/>
+            <pc:sldMk cId="1669914685" sldId="462"/>
+            <ac:spMk id="4" creationId="{C330968C-D51F-D138-1EDD-914244A319CF}"/>
+          </ac:spMkLst>
+        </pc:spChg>
+        <pc:spChg chg="mod">
+          <ac:chgData name="Jameson Teeters" userId="277cb491e97d6756" providerId="LiveId" clId="{01F63935-08AB-49D1-B378-3708E68EC584}" dt="2026-09-24T14:32:27.828" v="82" actId="20577"/>
+          <ac:spMkLst>
+            <pc:docMk/>
+            <pc:sldMk cId="1669914685" sldId="462"/>
+            <ac:spMk id="5" creationId="{B06630A5-280E-7693-0D06-502A7D11AFEB}"/>
+          </ac:spMkLst>
+        </pc:spChg>
+        <pc:spChg chg="mod">
+          <ac:chgData name="Jameson Teeters" userId="277cb491e97d6756" providerId="LiveId" clId="{01F63935-08AB-49D1-B378-3708E68EC584}" dt="2026-09-24T14:35:51.260" v="496" actId="20577"/>
+          <ac:spMkLst>
+            <pc:docMk/>
+            <pc:sldMk cId="1669914685" sldId="462"/>
+            <ac:spMk id="6" creationId="{01824338-D876-A3CE-8C26-E802C00D1067}"/>
+          </ac:spMkLst>
+        </pc:spChg>
+        <pc:spChg chg="mod">
+          <ac:chgData name="Jameson Teeters" userId="277cb491e97d6756" providerId="LiveId" clId="{01F63935-08AB-49D1-B378-3708E68EC584}" dt="2026-09-24T14:39:31.814" v="1012" actId="1076"/>
+          <ac:spMkLst>
+            <pc:docMk/>
+            <pc:sldMk cId="1669914685" sldId="462"/>
+            <ac:spMk id="7" creationId="{7A95B5B6-0053-73DA-0B16-5191CBDCFAC5}"/>
+          </ac:spMkLst>
+        </pc:spChg>
+        <pc:spChg chg="mod">
+          <ac:chgData name="Jameson Teeters" userId="277cb491e97d6756" providerId="LiveId" clId="{01F63935-08AB-49D1-B378-3708E68EC584}" dt="2026-09-24T14:39:18.529" v="1008" actId="1076"/>
+          <ac:spMkLst>
+            <pc:docMk/>
+            <pc:sldMk cId="1669914685" sldId="462"/>
+            <ac:spMk id="8" creationId="{9B9D0D1F-C2B1-ACE5-4285-BDE471A82D51}"/>
+          </ac:spMkLst>
+        </pc:spChg>
+        <pc:spChg chg="mod">
+          <ac:chgData name="Jameson Teeters" userId="277cb491e97d6756" providerId="LiveId" clId="{01F63935-08AB-49D1-B378-3708E68EC584}" dt="2026-09-24T14:39:16.116" v="1007" actId="1076"/>
+          <ac:spMkLst>
+            <pc:docMk/>
+            <pc:sldMk cId="1669914685" sldId="462"/>
+            <ac:spMk id="9" creationId="{809B85EE-D267-3F3D-5345-908F9F15EA43}"/>
+          </ac:spMkLst>
+        </pc:spChg>
+        <pc:spChg chg="mod">
+          <ac:chgData name="Jameson Teeters" userId="277cb491e97d6756" providerId="LiveId" clId="{01F63935-08AB-49D1-B378-3708E68EC584}" dt="2026-09-24T14:39:27.847" v="1011" actId="1076"/>
+          <ac:spMkLst>
+            <pc:docMk/>
+            <pc:sldMk cId="1669914685" sldId="462"/>
+            <ac:spMk id="10" creationId="{85439FFD-AB5E-F50D-818F-569D9226020C}"/>
+          </ac:spMkLst>
+        </pc:spChg>
+        <pc:spChg chg="mod">
+          <ac:chgData name="Jameson Teeters" userId="277cb491e97d6756" providerId="LiveId" clId="{01F63935-08AB-49D1-B378-3708E68EC584}" dt="2026-09-24T14:39:24.091" v="1010" actId="1076"/>
+          <ac:spMkLst>
+            <pc:docMk/>
+            <pc:sldMk cId="1669914685" sldId="462"/>
+            <ac:spMk id="11" creationId="{24E98293-0E85-6750-80FE-F1227DAD1C1E}"/>
+          </ac:spMkLst>
+        </pc:spChg>
+        <pc:spChg chg="mod">
+          <ac:chgData name="Jameson Teeters" userId="277cb491e97d6756" providerId="LiveId" clId="{01F63935-08AB-49D1-B378-3708E68EC584}" dt="2026-09-24T14:39:13.678" v="1006" actId="1076"/>
+          <ac:spMkLst>
+            <pc:docMk/>
+            <pc:sldMk cId="1669914685" sldId="462"/>
+            <ac:spMk id="12" creationId="{79D9CF1A-5C68-536A-F500-ED3107D1093D}"/>
+          </ac:spMkLst>
+        </pc:spChg>
+        <pc:spChg chg="mod">
+          <ac:chgData name="Jameson Teeters" userId="277cb491e97d6756" providerId="LiveId" clId="{01F63935-08AB-49D1-B378-3708E68EC584}" dt="2026-09-24T14:38:49.643" v="1000" actId="1076"/>
+          <ac:spMkLst>
+            <pc:docMk/>
+            <pc:sldMk cId="1669914685" sldId="462"/>
+            <ac:spMk id="13" creationId="{AF36A803-CD61-12FD-4BAC-FE7F75CC9B62}"/>
+          </ac:spMkLst>
+        </pc:spChg>
+        <pc:spChg chg="del">
+          <ac:chgData name="Jameson Teeters" userId="277cb491e97d6756" providerId="LiveId" clId="{01F63935-08AB-49D1-B378-3708E68EC584}" dt="2026-09-24T14:38:22.979" v="994" actId="478"/>
+          <ac:spMkLst>
+            <pc:docMk/>
+            <pc:sldMk cId="1669914685" sldId="462"/>
+            <ac:spMk id="14" creationId="{1FC0FE3A-EAFF-F748-D90A-33994B3B7E41}"/>
+          </ac:spMkLst>
+        </pc:spChg>
+        <pc:spChg chg="del">
+          <ac:chgData name="Jameson Teeters" userId="277cb491e97d6756" providerId="LiveId" clId="{01F63935-08AB-49D1-B378-3708E68EC584}" dt="2026-09-24T14:38:24.378" v="995" actId="478"/>
+          <ac:spMkLst>
+            <pc:docMk/>
+            <pc:sldMk cId="1669914685" sldId="462"/>
+            <ac:spMk id="15" creationId="{EB8BF797-8787-637E-0243-0ED233FE70F6}"/>
+          </ac:spMkLst>
+        </pc:spChg>
+        <pc:spChg chg="del">
+          <ac:chgData name="Jameson Teeters" userId="277cb491e97d6756" providerId="LiveId" clId="{01F63935-08AB-49D1-B378-3708E68EC584}" dt="2026-09-24T14:38:42.678" v="999" actId="478"/>
+          <ac:spMkLst>
+            <pc:docMk/>
+            <pc:sldMk cId="1669914685" sldId="462"/>
+            <ac:spMk id="16" creationId="{83D09E13-0EA1-5389-9A1A-BB2AEAB96355}"/>
+          </ac:spMkLst>
+        </pc:spChg>
+        <pc:spChg chg="del">
+          <ac:chgData name="Jameson Teeters" userId="277cb491e97d6756" providerId="LiveId" clId="{01F63935-08AB-49D1-B378-3708E68EC584}" dt="2026-09-24T14:38:36.962" v="997" actId="478"/>
+          <ac:spMkLst>
+            <pc:docMk/>
+            <pc:sldMk cId="1669914685" sldId="462"/>
+            <ac:spMk id="17" creationId="{B7B866A5-7A60-8682-833B-DA7BE6AD007E}"/>
+          </ac:spMkLst>
+        </pc:spChg>
+        <pc:spChg chg="del">
+          <ac:chgData name="Jameson Teeters" userId="277cb491e97d6756" providerId="LiveId" clId="{01F63935-08AB-49D1-B378-3708E68EC584}" dt="2026-09-24T14:38:38.638" v="998" actId="478"/>
+          <ac:spMkLst>
+            <pc:docMk/>
+            <pc:sldMk cId="1669914685" sldId="462"/>
+            <ac:spMk id="18" creationId="{6A03B9A2-B856-6A0F-F2B1-EE4911C9D3D2}"/>
+          </ac:spMkLst>
+        </pc:spChg>
+        <pc:picChg chg="add mod ord">
+          <ac:chgData name="Jameson Teeters" userId="277cb491e97d6756" providerId="LiveId" clId="{01F63935-08AB-49D1-B378-3708E68EC584}" dt="2026-09-24T14:31:38.190" v="2" actId="14100"/>
+          <ac:picMkLst>
+            <pc:docMk/>
+            <pc:sldMk cId="1669914685" sldId="462"/>
+            <ac:picMk id="21" creationId="{D7781136-FCF3-C2A1-6AD3-FC32D04FB48A}"/>
+          </ac:picMkLst>
+        </pc:picChg>
+      </pc:sldChg>
+    </pc:docChg>
+  </pc:docChgLst>
+</pc:chgInfo>
 </file>
 
 <file path=ppt/handoutMasters/handoutMaster1.xml><?xml version="1.0" encoding="utf-8"?>
@@ -10554,6 +10720,442 @@
 </file>
 
 <file path=ppt/slides/slide4.xml><?xml version="1.0" encoding="utf-8"?>
+<p:sld xmlns:a="http://schemas.openxmlformats.org/drawingml/2006/main" xmlns:r="http://schemas.openxmlformats.org/officeDocument/2006/relationships" xmlns:p="http://schemas.openxmlformats.org/presentationml/2006/main">
+  <p:cSld>
+    <p:spTree>
+      <p:nvGrpSpPr>
+        <p:cNvPr id="1" name=""/>
+        <p:cNvGrpSpPr/>
+        <p:nvPr/>
+      </p:nvGrpSpPr>
+      <p:grpSpPr>
+        <a:xfrm>
+          <a:off x="0" y="0"/>
+          <a:ext cx="0" cy="0"/>
+          <a:chOff x="0" y="0"/>
+          <a:chExt cx="0" cy="0"/>
+        </a:xfrm>
+      </p:grpSpPr>
+      <p:sp>
+        <p:nvSpPr>
+          <p:cNvPr id="2" name="Title 1">
+            <a:extLst>
+              <a:ext uri="{FF2B5EF4-FFF2-40B4-BE49-F238E27FC236}">
+                <a16:creationId xmlns:a16="http://schemas.microsoft.com/office/drawing/2014/main" id="{F45669BB-F1E9-25E6-255D-9DA1386B8F21}"/>
+              </a:ext>
+            </a:extLst>
+          </p:cNvPr>
+          <p:cNvSpPr>
+            <a:spLocks noGrp="1"/>
+          </p:cNvSpPr>
+          <p:nvPr>
+            <p:ph type="title"/>
+          </p:nvPr>
+        </p:nvSpPr>
+        <p:spPr>
+          <a:xfrm>
+            <a:off x="628027" y="623627"/>
+            <a:ext cx="5212080" cy="777240"/>
+          </a:xfrm>
+        </p:spPr>
+        <p:txBody>
+          <a:bodyPr/>
+          <a:lstStyle/>
+          <a:p>
+            <a:r>
+              <a:rPr lang="en-US" dirty="0"/>
+              <a:t>Chef (Provider)</a:t>
+            </a:r>
+          </a:p>
+        </p:txBody>
+      </p:sp>
+      <p:pic>
+        <p:nvPicPr>
+          <p:cNvPr id="21" name="Picture Placeholder 20">
+            <a:extLst>
+              <a:ext uri="{FF2B5EF4-FFF2-40B4-BE49-F238E27FC236}">
+                <a16:creationId xmlns:a16="http://schemas.microsoft.com/office/drawing/2014/main" id="{D7781136-FCF3-C2A1-6AD3-FC32D04FB48A}"/>
+              </a:ext>
+            </a:extLst>
+          </p:cNvPr>
+          <p:cNvPicPr>
+            <a:picLocks noGrp="1" noChangeAspect="1"/>
+          </p:cNvPicPr>
+          <p:nvPr>
+            <p:ph type="pic" sz="quarter" idx="10"/>
+          </p:nvPr>
+        </p:nvPicPr>
+        <p:blipFill>
+          <a:blip r:embed="rId2"/>
+          <a:srcRect l="8558" r="8558"/>
+          <a:stretch>
+            <a:fillRect/>
+          </a:stretch>
+        </p:blipFill>
+        <p:spPr>
+          <a:xfrm>
+            <a:off x="0" y="1828800"/>
+            <a:ext cx="5669280" cy="5556738"/>
+          </a:xfrm>
+          <a:prstGeom prst="rect">
+            <a:avLst/>
+          </a:prstGeom>
+          <a:noFill/>
+        </p:spPr>
+      </p:pic>
+      <p:sp>
+        <p:nvSpPr>
+          <p:cNvPr id="5" name="Text Placeholder 4">
+            <a:extLst>
+              <a:ext uri="{FF2B5EF4-FFF2-40B4-BE49-F238E27FC236}">
+                <a16:creationId xmlns:a16="http://schemas.microsoft.com/office/drawing/2014/main" id="{B06630A5-280E-7693-0D06-502A7D11AFEB}"/>
+              </a:ext>
+            </a:extLst>
+          </p:cNvPr>
+          <p:cNvSpPr>
+            <a:spLocks noGrp="1"/>
+          </p:cNvSpPr>
+          <p:nvPr>
+            <p:ph type="body" sz="half" idx="11"/>
+          </p:nvPr>
+        </p:nvSpPr>
+        <p:spPr/>
+        <p:txBody>
+          <a:bodyPr/>
+          <a:lstStyle/>
+          <a:p>
+            <a:r>
+              <a:rPr lang="en-US" dirty="0"/>
+              <a:t>Providers will also start from the Index page</a:t>
+            </a:r>
+          </a:p>
+        </p:txBody>
+      </p:sp>
+      <p:sp>
+        <p:nvSpPr>
+          <p:cNvPr id="6" name="Text Placeholder 5">
+            <a:extLst>
+              <a:ext uri="{FF2B5EF4-FFF2-40B4-BE49-F238E27FC236}">
+                <a16:creationId xmlns:a16="http://schemas.microsoft.com/office/drawing/2014/main" id="{01824338-D876-A3CE-8C26-E802C00D1067}"/>
+              </a:ext>
+            </a:extLst>
+          </p:cNvPr>
+          <p:cNvSpPr>
+            <a:spLocks noGrp="1"/>
+          </p:cNvSpPr>
+          <p:nvPr>
+            <p:ph type="body" sz="half" idx="12"/>
+          </p:nvPr>
+        </p:nvSpPr>
+        <p:spPr>
+          <a:xfrm>
+            <a:off x="6351894" y="822960"/>
+            <a:ext cx="4937760" cy="1292961"/>
+          </a:xfrm>
+        </p:spPr>
+        <p:txBody>
+          <a:bodyPr/>
+          <a:lstStyle/>
+          <a:p>
+            <a:r>
+              <a:rPr lang="en-US" dirty="0"/>
+              <a:t>Anything that the providers  want to do will need to be from their personal dashboard page.</a:t>
+            </a:r>
+          </a:p>
+          <a:p>
+            <a:endParaRPr lang="en-US" dirty="0"/>
+          </a:p>
+          <a:p>
+            <a:endParaRPr lang="en-US" dirty="0"/>
+          </a:p>
+          <a:p>
+            <a:r>
+              <a:rPr lang="en-US" dirty="0"/>
+              <a:t>First, they will have to click on the “I’m a Provider button, this will take them to the provider login. Also, they could press the Login button if they already have a valid account</a:t>
+            </a:r>
+          </a:p>
+        </p:txBody>
+      </p:sp>
+      <p:sp>
+        <p:nvSpPr>
+          <p:cNvPr id="7" name="Text Placeholder 6">
+            <a:extLst>
+              <a:ext uri="{FF2B5EF4-FFF2-40B4-BE49-F238E27FC236}">
+                <a16:creationId xmlns:a16="http://schemas.microsoft.com/office/drawing/2014/main" id="{7A95B5B6-0053-73DA-0B16-5191CBDCFAC5}"/>
+              </a:ext>
+            </a:extLst>
+          </p:cNvPr>
+          <p:cNvSpPr>
+            <a:spLocks noGrp="1"/>
+          </p:cNvSpPr>
+          <p:nvPr>
+            <p:ph type="body" sz="half" idx="21"/>
+          </p:nvPr>
+        </p:nvSpPr>
+        <p:spPr>
+          <a:xfrm>
+            <a:off x="6351894" y="2271496"/>
+            <a:ext cx="4937760" cy="365760"/>
+          </a:xfrm>
+        </p:spPr>
+        <p:txBody>
+          <a:bodyPr/>
+          <a:lstStyle/>
+          <a:p>
+            <a:r>
+              <a:rPr lang="en-US" dirty="0"/>
+              <a:t>Provider Information                </a:t>
+            </a:r>
+          </a:p>
+        </p:txBody>
+      </p:sp>
+      <p:sp>
+        <p:nvSpPr>
+          <p:cNvPr id="8" name="Text Placeholder 7">
+            <a:extLst>
+              <a:ext uri="{FF2B5EF4-FFF2-40B4-BE49-F238E27FC236}">
+                <a16:creationId xmlns:a16="http://schemas.microsoft.com/office/drawing/2014/main" id="{9B9D0D1F-C2B1-ACE5-4285-BDE471A82D51}"/>
+              </a:ext>
+            </a:extLst>
+          </p:cNvPr>
+          <p:cNvSpPr>
+            <a:spLocks noGrp="1"/>
+          </p:cNvSpPr>
+          <p:nvPr>
+            <p:ph type="body" sz="quarter" idx="40"/>
+          </p:nvPr>
+        </p:nvSpPr>
+        <p:spPr>
+          <a:xfrm>
+            <a:off x="6202818" y="2781370"/>
+            <a:ext cx="613184" cy="548640"/>
+          </a:xfrm>
+        </p:spPr>
+        <p:txBody>
+          <a:bodyPr/>
+          <a:lstStyle/>
+          <a:p>
+            <a:r>
+              <a:rPr lang="en-US" dirty="0"/>
+              <a:t>1</a:t>
+            </a:r>
+          </a:p>
+        </p:txBody>
+      </p:sp>
+      <p:sp>
+        <p:nvSpPr>
+          <p:cNvPr id="9" name="Text Placeholder 8">
+            <a:extLst>
+              <a:ext uri="{FF2B5EF4-FFF2-40B4-BE49-F238E27FC236}">
+                <a16:creationId xmlns:a16="http://schemas.microsoft.com/office/drawing/2014/main" id="{809B85EE-D267-3F3D-5345-908F9F15EA43}"/>
+              </a:ext>
+            </a:extLst>
+          </p:cNvPr>
+          <p:cNvSpPr>
+            <a:spLocks noGrp="1"/>
+          </p:cNvSpPr>
+          <p:nvPr>
+            <p:ph type="body" sz="half" idx="22"/>
+          </p:nvPr>
+        </p:nvSpPr>
+        <p:spPr>
+          <a:xfrm>
+            <a:off x="6900534" y="3055690"/>
+            <a:ext cx="1920240" cy="1097280"/>
+          </a:xfrm>
+        </p:spPr>
+        <p:txBody>
+          <a:bodyPr/>
+          <a:lstStyle/>
+          <a:p>
+            <a:r>
+              <a:rPr lang="en-US" dirty="0"/>
+              <a:t>Any provider’s information can be found by clicking the “About Me” button below their profile on the index page.</a:t>
+            </a:r>
+          </a:p>
+        </p:txBody>
+      </p:sp>
+      <p:sp>
+        <p:nvSpPr>
+          <p:cNvPr id="10" name="Text Placeholder 9">
+            <a:extLst>
+              <a:ext uri="{FF2B5EF4-FFF2-40B4-BE49-F238E27FC236}">
+                <a16:creationId xmlns:a16="http://schemas.microsoft.com/office/drawing/2014/main" id="{85439FFD-AB5E-F50D-818F-569D9226020C}"/>
+              </a:ext>
+            </a:extLst>
+          </p:cNvPr>
+          <p:cNvSpPr>
+            <a:spLocks noGrp="1"/>
+          </p:cNvSpPr>
+          <p:nvPr>
+            <p:ph type="body" sz="quarter" idx="41"/>
+          </p:nvPr>
+        </p:nvSpPr>
+        <p:spPr>
+          <a:xfrm>
+            <a:off x="8905306" y="2989337"/>
+            <a:ext cx="613184" cy="548640"/>
+          </a:xfrm>
+        </p:spPr>
+        <p:txBody>
+          <a:bodyPr/>
+          <a:lstStyle/>
+          <a:p>
+            <a:r>
+              <a:rPr lang="en-US" dirty="0"/>
+              <a:t>2</a:t>
+            </a:r>
+          </a:p>
+        </p:txBody>
+      </p:sp>
+      <p:sp>
+        <p:nvSpPr>
+          <p:cNvPr id="11" name="Text Placeholder 10">
+            <a:extLst>
+              <a:ext uri="{FF2B5EF4-FFF2-40B4-BE49-F238E27FC236}">
+                <a16:creationId xmlns:a16="http://schemas.microsoft.com/office/drawing/2014/main" id="{24E98293-0E85-6750-80FE-F1227DAD1C1E}"/>
+              </a:ext>
+            </a:extLst>
+          </p:cNvPr>
+          <p:cNvSpPr>
+            <a:spLocks noGrp="1"/>
+          </p:cNvSpPr>
+          <p:nvPr>
+            <p:ph type="body" sz="half" idx="32"/>
+          </p:nvPr>
+        </p:nvSpPr>
+        <p:spPr>
+          <a:xfrm>
+            <a:off x="9518490" y="3263657"/>
+            <a:ext cx="1920240" cy="1097280"/>
+          </a:xfrm>
+        </p:spPr>
+        <p:txBody>
+          <a:bodyPr/>
+          <a:lstStyle/>
+          <a:p>
+            <a:r>
+              <a:rPr lang="en-US" dirty="0"/>
+              <a:t>Providers could also navigate to their meals, (Pantry page for now), by pressing the “View Meals” button</a:t>
+            </a:r>
+          </a:p>
+        </p:txBody>
+      </p:sp>
+      <p:sp>
+        <p:nvSpPr>
+          <p:cNvPr id="12" name="Text Placeholder 11">
+            <a:extLst>
+              <a:ext uri="{FF2B5EF4-FFF2-40B4-BE49-F238E27FC236}">
+                <a16:creationId xmlns:a16="http://schemas.microsoft.com/office/drawing/2014/main" id="{79D9CF1A-5C68-536A-F500-ED3107D1093D}"/>
+              </a:ext>
+            </a:extLst>
+          </p:cNvPr>
+          <p:cNvSpPr>
+            <a:spLocks noGrp="1"/>
+          </p:cNvSpPr>
+          <p:nvPr>
+            <p:ph type="body" sz="quarter" idx="42"/>
+          </p:nvPr>
+        </p:nvSpPr>
+        <p:spPr>
+          <a:xfrm>
+            <a:off x="6287350" y="4233266"/>
+            <a:ext cx="613184" cy="548640"/>
+          </a:xfrm>
+        </p:spPr>
+        <p:txBody>
+          <a:bodyPr/>
+          <a:lstStyle/>
+          <a:p>
+            <a:r>
+              <a:rPr lang="en-US" dirty="0"/>
+              <a:t>3</a:t>
+            </a:r>
+          </a:p>
+        </p:txBody>
+      </p:sp>
+      <p:sp>
+        <p:nvSpPr>
+          <p:cNvPr id="13" name="Text Placeholder 12">
+            <a:extLst>
+              <a:ext uri="{FF2B5EF4-FFF2-40B4-BE49-F238E27FC236}">
+                <a16:creationId xmlns:a16="http://schemas.microsoft.com/office/drawing/2014/main" id="{AF36A803-CD61-12FD-4BAC-FE7F75CC9B62}"/>
+              </a:ext>
+            </a:extLst>
+          </p:cNvPr>
+          <p:cNvSpPr>
+            <a:spLocks noGrp="1"/>
+          </p:cNvSpPr>
+          <p:nvPr>
+            <p:ph type="body" sz="half" idx="33"/>
+          </p:nvPr>
+        </p:nvSpPr>
+        <p:spPr>
+          <a:xfrm>
+            <a:off x="6794893" y="4507586"/>
+            <a:ext cx="4354642" cy="1097280"/>
+          </a:xfrm>
+        </p:spPr>
+        <p:txBody>
+          <a:bodyPr/>
+          <a:lstStyle/>
+          <a:p>
+            <a:r>
+              <a:rPr lang="en-US" dirty="0"/>
+              <a:t>Lastly, providers can see any details on their meals located on their dashboard by pressing the “View Meal” button below each meal in their personal </a:t>
+            </a:r>
+            <a:r>
+              <a:rPr lang="en-US" dirty="0" err="1"/>
+              <a:t>Cataslog</a:t>
+            </a:r>
+            <a:endParaRPr lang="en-US" dirty="0"/>
+          </a:p>
+        </p:txBody>
+      </p:sp>
+      <p:sp>
+        <p:nvSpPr>
+          <p:cNvPr id="19" name="Slide Number Placeholder 18">
+            <a:extLst>
+              <a:ext uri="{FF2B5EF4-FFF2-40B4-BE49-F238E27FC236}">
+                <a16:creationId xmlns:a16="http://schemas.microsoft.com/office/drawing/2014/main" id="{DEF8E22D-BBCB-E0B8-026E-5EC6BABC1D47}"/>
+              </a:ext>
+            </a:extLst>
+          </p:cNvPr>
+          <p:cNvSpPr>
+            <a:spLocks noGrp="1"/>
+          </p:cNvSpPr>
+          <p:nvPr>
+            <p:ph type="sldNum" sz="quarter" idx="4"/>
+          </p:nvPr>
+        </p:nvSpPr>
+        <p:spPr/>
+        <p:txBody>
+          <a:bodyPr/>
+          <a:lstStyle/>
+          <a:p>
+            <a:fld id="{745CA84A-544F-4B6B-BC9A-925394EE73B5}" type="slidenum">
+              <a:rPr lang="en-US" smtClean="0"/>
+              <a:pPr/>
+              <a:t>3</a:t>
+            </a:fld>
+            <a:endParaRPr lang="en-US" dirty="0"/>
+          </a:p>
+        </p:txBody>
+      </p:sp>
+    </p:spTree>
+    <p:extLst>
+      <p:ext uri="{BB962C8B-B14F-4D97-AF65-F5344CB8AC3E}">
+        <p14:creationId xmlns:p14="http://schemas.microsoft.com/office/powerpoint/2010/main" val="1669914685"/>
+      </p:ext>
+    </p:extLst>
+  </p:cSld>
+  <p:clrMapOvr>
+    <a:masterClrMapping/>
+  </p:clrMapOvr>
+</p:sld>
+</file>
+
+<file path=ppt/slides/slide5.xml><?xml version="1.0" encoding="utf-8"?>
 <p:sld xmlns:a="http://schemas.openxmlformats.org/drawingml/2006/main" xmlns:r="http://schemas.openxmlformats.org/officeDocument/2006/relationships" xmlns:p="http://schemas.openxmlformats.org/presentationml/2006/main">
   <p:cSld>
     <p:spTree>
@@ -11477,6 +12079,26 @@
 </file>
 
 <file path=customXml/item1.xml><?xml version="1.0" encoding="utf-8"?>
+<p:properties xmlns:p="http://schemas.microsoft.com/office/2006/metadata/properties" xmlns:xsi="http://www.w3.org/2001/XMLSchema-instance" xmlns:pc="http://schemas.microsoft.com/office/infopath/2007/PartnerControls">
+  <documentManagement>
+    <_ip_UnifiedCompliancePolicyUIAction xmlns="http://schemas.microsoft.com/sharepoint/v3" xsi:nil="true"/>
+    <Image xmlns="71af3243-3dd4-4a8d-8c0d-dd76da1f02a5">
+      <Url xsi:nil="true"/>
+      <Description xsi:nil="true"/>
+    </Image>
+    <Status xmlns="71af3243-3dd4-4a8d-8c0d-dd76da1f02a5">Not started</Status>
+    <Background xmlns="71af3243-3dd4-4a8d-8c0d-dd76da1f02a5">false</Background>
+    <_ip_UnifiedCompliancePolicyProperties xmlns="http://schemas.microsoft.com/sharepoint/v3" xsi:nil="true"/>
+    <ImageTagsTaxHTField xmlns="71af3243-3dd4-4a8d-8c0d-dd76da1f02a5">
+      <Terms xmlns="http://schemas.microsoft.com/office/infopath/2007/PartnerControls"/>
+    </ImageTagsTaxHTField>
+    <TaxCatchAll xmlns="230e9df3-be65-4c73-a93b-d1236ebd677e" xsi:nil="true"/>
+    <MediaServiceKeyPoints xmlns="71af3243-3dd4-4a8d-8c0d-dd76da1f02a5" xsi:nil="true"/>
+  </documentManagement>
+</p:properties>
+</file>
+
+<file path=customXml/item2.xml><?xml version="1.0" encoding="utf-8"?>
 <ct:contentTypeSchema xmlns:ct="http://schemas.microsoft.com/office/2006/metadata/contentType" xmlns:ma="http://schemas.microsoft.com/office/2006/metadata/properties/metaAttributes" ct:_="" ma:_="" ma:contentTypeName="Document" ma:contentTypeID="0x01010079F111ED35F8CC479449609E8A0923A6" ma:contentTypeVersion="27" ma:contentTypeDescription="Create a new document." ma:contentTypeScope="" ma:versionID="c6f9a84f66a9c8b9a21755b9ffafb945">
   <xsd:schema xmlns:xsd="http://www.w3.org/2001/XMLSchema" xmlns:xs="http://www.w3.org/2001/XMLSchema" xmlns:p="http://schemas.microsoft.com/office/2006/metadata/properties" xmlns:ns1="http://schemas.microsoft.com/sharepoint/v3" xmlns:ns2="71af3243-3dd4-4a8d-8c0d-dd76da1f02a5" xmlns:ns3="16c05727-aa75-4e4a-9b5f-8a80a1165891" xmlns:ns4="230e9df3-be65-4c73-a93b-d1236ebd677e" targetNamespace="http://schemas.microsoft.com/office/2006/metadata/properties" ma:root="true" ma:fieldsID="27df39e3e7036dff54f89ddd5805ce72" ns1:_="" ns2:_="" ns3:_="" ns4:_="">
     <xsd:import namespace="http://schemas.microsoft.com/sharepoint/v3"/>
@@ -11782,26 +12404,6 @@
 </ct:contentTypeSchema>
 </file>
 
-<file path=customXml/item2.xml><?xml version="1.0" encoding="utf-8"?>
-<p:properties xmlns:p="http://schemas.microsoft.com/office/2006/metadata/properties" xmlns:xsi="http://www.w3.org/2001/XMLSchema-instance" xmlns:pc="http://schemas.microsoft.com/office/infopath/2007/PartnerControls">
-  <documentManagement>
-    <_ip_UnifiedCompliancePolicyUIAction xmlns="http://schemas.microsoft.com/sharepoint/v3" xsi:nil="true"/>
-    <Image xmlns="71af3243-3dd4-4a8d-8c0d-dd76da1f02a5">
-      <Url xsi:nil="true"/>
-      <Description xsi:nil="true"/>
-    </Image>
-    <Status xmlns="71af3243-3dd4-4a8d-8c0d-dd76da1f02a5">Not started</Status>
-    <Background xmlns="71af3243-3dd4-4a8d-8c0d-dd76da1f02a5">false</Background>
-    <_ip_UnifiedCompliancePolicyProperties xmlns="http://schemas.microsoft.com/sharepoint/v3" xsi:nil="true"/>
-    <ImageTagsTaxHTField xmlns="71af3243-3dd4-4a8d-8c0d-dd76da1f02a5">
-      <Terms xmlns="http://schemas.microsoft.com/office/infopath/2007/PartnerControls"/>
-    </ImageTagsTaxHTField>
-    <TaxCatchAll xmlns="230e9df3-be65-4c73-a93b-d1236ebd677e" xsi:nil="true"/>
-    <MediaServiceKeyPoints xmlns="71af3243-3dd4-4a8d-8c0d-dd76da1f02a5" xsi:nil="true"/>
-  </documentManagement>
-</p:properties>
-</file>
-
 <file path=customXml/item3.xml><?xml version="1.0" encoding="utf-8"?>
 <?mso-contentType ?>
 <FormTemplates xmlns="http://schemas.microsoft.com/sharepoint/v3/contenttype/forms">
@@ -11812,6 +12414,18 @@
 </file>
 
 <file path=customXml/itemProps1.xml><?xml version="1.0" encoding="utf-8"?>
+<ds:datastoreItem xmlns:ds="http://schemas.openxmlformats.org/officeDocument/2006/customXml" ds:itemID="{366CA61D-72DC-47D2-B704-D41B536A8ABF}">
+  <ds:schemaRefs>
+    <ds:schemaRef ds:uri="http://schemas.microsoft.com/office/2006/metadata/properties"/>
+    <ds:schemaRef ds:uri="http://schemas.microsoft.com/office/infopath/2007/PartnerControls"/>
+    <ds:schemaRef ds:uri="http://schemas.microsoft.com/sharepoint/v3"/>
+    <ds:schemaRef ds:uri="71af3243-3dd4-4a8d-8c0d-dd76da1f02a5"/>
+    <ds:schemaRef ds:uri="230e9df3-be65-4c73-a93b-d1236ebd677e"/>
+  </ds:schemaRefs>
+</ds:datastoreItem>
+</file>
+
+<file path=customXml/itemProps2.xml><?xml version="1.0" encoding="utf-8"?>
 <ds:datastoreItem xmlns:ds="http://schemas.openxmlformats.org/officeDocument/2006/customXml" ds:itemID="{E7075E2F-4690-41A1-9EE7-51CB5902AC27}">
   <ds:schemaRefs>
     <ds:schemaRef ds:uri="http://schemas.microsoft.com/office/2006/metadata/contentType"/>
@@ -11832,18 +12446,6 @@
 </ds:datastoreItem>
 </file>
 
-<file path=customXml/itemProps2.xml><?xml version="1.0" encoding="utf-8"?>
-<ds:datastoreItem xmlns:ds="http://schemas.openxmlformats.org/officeDocument/2006/customXml" ds:itemID="{366CA61D-72DC-47D2-B704-D41B536A8ABF}">
-  <ds:schemaRefs>
-    <ds:schemaRef ds:uri="http://schemas.microsoft.com/office/2006/metadata/properties"/>
-    <ds:schemaRef ds:uri="http://schemas.microsoft.com/office/infopath/2007/PartnerControls"/>
-    <ds:schemaRef ds:uri="http://schemas.microsoft.com/sharepoint/v3"/>
-    <ds:schemaRef ds:uri="71af3243-3dd4-4a8d-8c0d-dd76da1f02a5"/>
-    <ds:schemaRef ds:uri="230e9df3-be65-4c73-a93b-d1236ebd677e"/>
-  </ds:schemaRefs>
-</ds:datastoreItem>
-</file>
-
 <file path=customXml/itemProps3.xml><?xml version="1.0" encoding="utf-8"?>
 <ds:datastoreItem xmlns:ds="http://schemas.openxmlformats.org/officeDocument/2006/customXml" ds:itemID="{02BBBACA-7C3E-4908-8442-1DC4C9DFCAA1}">
   <ds:schemaRefs>

</xml_diff>

<commit_message>
Added Provider files and exceptions
</commit_message>
<xml_diff>
--- a/dsonjteetersprototype.pptx
+++ b/dsonjteetersprototype.pptx
@@ -137,8 +137,8 @@
 <pc:chgInfo xmlns:a="http://schemas.openxmlformats.org/drawingml/2006/main" xmlns:r="http://schemas.openxmlformats.org/officeDocument/2006/relationships" xmlns:ac="http://schemas.microsoft.com/office/drawing/2013/main/command" xmlns:pc="http://schemas.microsoft.com/office/powerpoint/2013/main/command">
   <pc:docChgLst>
     <pc:chgData name="Jameson Teeters" userId="277cb491e97d6756" providerId="LiveId" clId="{01F63935-08AB-49D1-B378-3708E68EC584}"/>
-    <pc:docChg chg="custSel addSld modSld">
-      <pc:chgData name="Jameson Teeters" userId="277cb491e97d6756" providerId="LiveId" clId="{01F63935-08AB-49D1-B378-3708E68EC584}" dt="2026-09-24T14:39:31.814" v="1012" actId="1076"/>
+    <pc:docChg chg="custSel addSld delSld modSld">
+      <pc:chgData name="Jameson Teeters" userId="277cb491e97d6756" providerId="LiveId" clId="{01F63935-08AB-49D1-B378-3708E68EC584}" dt="2026-09-24T15:02:47.973" v="1014" actId="2696"/>
       <pc:docMkLst>
         <pc:docMk/>
       </pc:docMkLst>
@@ -292,6 +292,13 @@
             <ac:picMk id="21" creationId="{D7781136-FCF3-C2A1-6AD3-FC32D04FB48A}"/>
           </ac:picMkLst>
         </pc:picChg>
+      </pc:sldChg>
+      <pc:sldChg chg="new del">
+        <pc:chgData name="Jameson Teeters" userId="277cb491e97d6756" providerId="LiveId" clId="{01F63935-08AB-49D1-B378-3708E68EC584}" dt="2026-09-24T15:02:47.973" v="1014" actId="2696"/>
+        <pc:sldMkLst>
+          <pc:docMk/>
+          <pc:sldMk cId="4293105669" sldId="463"/>
+        </pc:sldMkLst>
       </pc:sldChg>
     </pc:docChg>
   </pc:docChgLst>

</xml_diff>